<commit_message>
UI skeleton boilerplate + data model
1). Renders application through React router provider.
2). Defines app as a browser router data object.
3). Defines the app shell as a Navigation Layer, Display Layer, and Footer.
4). Adds placeholder app shell pages.
5). Adds NeuroTraceR data models
</commit_message>
<xml_diff>
--- a/design.pptx
+++ b/design.pptx
@@ -202,7 +202,7 @@
           <a:p>
             <a:fld id="{6FA4EDF4-EE0E-49B4-B826-F9C1BBE68B05}" type="datetimeFigureOut">
               <a:rPr lang="en-IE" smtClean="0"/>
-              <a:t>12/10/2026</a:t>
+              <a:t>13/10/2026</a:t>
             </a:fld>
             <a:endParaRPr lang="en-IE"/>
           </a:p>
@@ -706,7 +706,7 @@
           <a:p>
             <a:fld id="{830E50AA-C841-416D-81BB-884671257748}" type="datetimeFigureOut">
               <a:rPr lang="en-IE" smtClean="0"/>
-              <a:t>12/10/2026</a:t>
+              <a:t>13/10/2026</a:t>
             </a:fld>
             <a:endParaRPr lang="en-IE"/>
           </a:p>
@@ -906,7 +906,7 @@
           <a:p>
             <a:fld id="{830E50AA-C841-416D-81BB-884671257748}" type="datetimeFigureOut">
               <a:rPr lang="en-IE" smtClean="0"/>
-              <a:t>12/10/2026</a:t>
+              <a:t>13/10/2026</a:t>
             </a:fld>
             <a:endParaRPr lang="en-IE"/>
           </a:p>
@@ -1116,7 +1116,7 @@
           <a:p>
             <a:fld id="{830E50AA-C841-416D-81BB-884671257748}" type="datetimeFigureOut">
               <a:rPr lang="en-IE" smtClean="0"/>
-              <a:t>12/10/2026</a:t>
+              <a:t>13/10/2026</a:t>
             </a:fld>
             <a:endParaRPr lang="en-IE"/>
           </a:p>
@@ -1316,7 +1316,7 @@
           <a:p>
             <a:fld id="{830E50AA-C841-416D-81BB-884671257748}" type="datetimeFigureOut">
               <a:rPr lang="en-IE" smtClean="0"/>
-              <a:t>12/10/2026</a:t>
+              <a:t>13/10/2026</a:t>
             </a:fld>
             <a:endParaRPr lang="en-IE"/>
           </a:p>
@@ -1592,7 +1592,7 @@
           <a:p>
             <a:fld id="{830E50AA-C841-416D-81BB-884671257748}" type="datetimeFigureOut">
               <a:rPr lang="en-IE" smtClean="0"/>
-              <a:t>12/10/2026</a:t>
+              <a:t>13/10/2026</a:t>
             </a:fld>
             <a:endParaRPr lang="en-IE"/>
           </a:p>
@@ -1860,7 +1860,7 @@
           <a:p>
             <a:fld id="{830E50AA-C841-416D-81BB-884671257748}" type="datetimeFigureOut">
               <a:rPr lang="en-IE" smtClean="0"/>
-              <a:t>12/10/2026</a:t>
+              <a:t>13/10/2026</a:t>
             </a:fld>
             <a:endParaRPr lang="en-IE"/>
           </a:p>
@@ -2275,7 +2275,7 @@
           <a:p>
             <a:fld id="{830E50AA-C841-416D-81BB-884671257748}" type="datetimeFigureOut">
               <a:rPr lang="en-IE" smtClean="0"/>
-              <a:t>12/10/2026</a:t>
+              <a:t>13/10/2026</a:t>
             </a:fld>
             <a:endParaRPr lang="en-IE"/>
           </a:p>
@@ -2417,7 +2417,7 @@
           <a:p>
             <a:fld id="{830E50AA-C841-416D-81BB-884671257748}" type="datetimeFigureOut">
               <a:rPr lang="en-IE" smtClean="0"/>
-              <a:t>12/10/2026</a:t>
+              <a:t>13/10/2026</a:t>
             </a:fld>
             <a:endParaRPr lang="en-IE"/>
           </a:p>
@@ -2530,7 +2530,7 @@
           <a:p>
             <a:fld id="{830E50AA-C841-416D-81BB-884671257748}" type="datetimeFigureOut">
               <a:rPr lang="en-IE" smtClean="0"/>
-              <a:t>12/10/2026</a:t>
+              <a:t>13/10/2026</a:t>
             </a:fld>
             <a:endParaRPr lang="en-IE"/>
           </a:p>
@@ -2843,7 +2843,7 @@
           <a:p>
             <a:fld id="{830E50AA-C841-416D-81BB-884671257748}" type="datetimeFigureOut">
               <a:rPr lang="en-IE" smtClean="0"/>
-              <a:t>12/10/2026</a:t>
+              <a:t>13/10/2026</a:t>
             </a:fld>
             <a:endParaRPr lang="en-IE"/>
           </a:p>
@@ -3132,7 +3132,7 @@
           <a:p>
             <a:fld id="{830E50AA-C841-416D-81BB-884671257748}" type="datetimeFigureOut">
               <a:rPr lang="en-IE" smtClean="0"/>
-              <a:t>12/10/2026</a:t>
+              <a:t>13/10/2026</a:t>
             </a:fld>
             <a:endParaRPr lang="en-IE"/>
           </a:p>
@@ -3375,7 +3375,7 @@
           <a:p>
             <a:fld id="{830E50AA-C841-416D-81BB-884671257748}" type="datetimeFigureOut">
               <a:rPr lang="en-IE" smtClean="0"/>
-              <a:t>12/10/2026</a:t>
+              <a:t>13/10/2026</a:t>
             </a:fld>
             <a:endParaRPr lang="en-IE"/>
           </a:p>
@@ -4153,7 +4153,7 @@
                   <a:pPr algn="ctr"/>
                   <a:r>
                     <a:rPr lang="en-IE" b="1" dirty="0"/>
-                    <a:t>Documents</a:t>
+                    <a:t>Catalogue</a:t>
                   </a:r>
                 </a:p>
               </p:txBody>
@@ -4299,8 +4299,8 @@
         </p:nvSpPr>
         <p:spPr>
           <a:xfrm>
-            <a:off x="9836098" y="1327931"/>
-            <a:ext cx="1413540" cy="369332"/>
+            <a:off x="9403577" y="1327931"/>
+            <a:ext cx="1963024" cy="369332"/>
           </a:xfrm>
           <a:prstGeom prst="rect">
             <a:avLst/>
@@ -4316,7 +4316,7 @@
             <a:pPr algn="ctr"/>
             <a:r>
               <a:rPr lang="en-IE" i="1" dirty="0"/>
-              <a:t>Nav Menu</a:t>
+              <a:t>Navigation Layer</a:t>
             </a:r>
           </a:p>
         </p:txBody>
@@ -4352,7 +4352,7 @@
             <a:pPr algn="ctr"/>
             <a:r>
               <a:rPr lang="en-IE" i="1" dirty="0"/>
-              <a:t>App Component</a:t>
+              <a:t>Display Layer</a:t>
             </a:r>
           </a:p>
         </p:txBody>
@@ -5494,7 +5494,7 @@
           <a:p>
             <a:r>
               <a:rPr lang="en-IE" b="1" i="1" dirty="0"/>
-              <a:t>Data Model</a:t>
+              <a:t>Annotatable Data Model</a:t>
             </a:r>
           </a:p>
         </p:txBody>
@@ -5513,7 +5513,7 @@
         </p:nvSpPr>
         <p:spPr>
           <a:xfrm>
-            <a:off x="1015999" y="1481667"/>
+            <a:off x="1015999" y="1545465"/>
             <a:ext cx="2142067" cy="973667"/>
           </a:xfrm>
           <a:prstGeom prst="rect">
@@ -5562,7 +5562,7 @@
             <a:pPr algn="ctr"/>
             <a:r>
               <a:rPr lang="en-IE" b="1" dirty="0"/>
-              <a:t>Workspace</a:t>
+              <a:t>Catalogue</a:t>
             </a:r>
           </a:p>
         </p:txBody>
@@ -5581,7 +5581,7 @@
         </p:nvGrpSpPr>
         <p:grpSpPr>
           <a:xfrm>
-            <a:off x="1727200" y="2599267"/>
+            <a:off x="1727200" y="2663065"/>
             <a:ext cx="804333" cy="381000"/>
             <a:chOff x="1727200" y="2599267"/>
             <a:chExt cx="1329267" cy="381000"/>
@@ -5674,7 +5674,7 @@
         </p:nvSpPr>
         <p:spPr>
           <a:xfrm>
-            <a:off x="2641598" y="2599267"/>
+            <a:off x="2641598" y="2663065"/>
             <a:ext cx="2963331" cy="973667"/>
           </a:xfrm>
           <a:prstGeom prst="rect">
@@ -5742,7 +5742,7 @@
         </p:nvGrpSpPr>
         <p:grpSpPr>
           <a:xfrm>
-            <a:off x="4699000" y="3784600"/>
+            <a:off x="4699000" y="3848398"/>
             <a:ext cx="804333" cy="381000"/>
             <a:chOff x="1727200" y="2599267"/>
             <a:chExt cx="1329267" cy="381000"/>
@@ -5835,7 +5835,7 @@
         </p:nvSpPr>
         <p:spPr>
           <a:xfrm>
-            <a:off x="5664199" y="3738035"/>
+            <a:off x="5664199" y="3801833"/>
             <a:ext cx="1828802" cy="850898"/>
           </a:xfrm>
           <a:prstGeom prst="rect">
@@ -5903,7 +5903,7 @@
         </p:nvGrpSpPr>
         <p:grpSpPr>
           <a:xfrm>
-            <a:off x="6578600" y="4715933"/>
+            <a:off x="6578600" y="4779731"/>
             <a:ext cx="804333" cy="381000"/>
             <a:chOff x="1727200" y="2599267"/>
             <a:chExt cx="1329267" cy="381000"/>
@@ -5996,7 +5996,7 @@
         </p:nvSpPr>
         <p:spPr>
           <a:xfrm>
-            <a:off x="7594600" y="4671484"/>
+            <a:off x="7594600" y="4735282"/>
             <a:ext cx="1828802" cy="850898"/>
           </a:xfrm>
           <a:prstGeom prst="rect">
@@ -6064,7 +6064,7 @@
         </p:nvCxnSpPr>
         <p:spPr>
           <a:xfrm>
-            <a:off x="6578600" y="5096933"/>
+            <a:off x="6578600" y="5160731"/>
             <a:ext cx="0" cy="956734"/>
           </a:xfrm>
           <a:prstGeom prst="line">
@@ -6100,7 +6100,7 @@
         </p:nvCxnSpPr>
         <p:spPr>
           <a:xfrm>
-            <a:off x="6578600" y="6053667"/>
+            <a:off x="6578600" y="6117465"/>
             <a:ext cx="804333" cy="0"/>
           </a:xfrm>
           <a:prstGeom prst="line">
@@ -6136,7 +6136,7 @@
         </p:nvSpPr>
         <p:spPr>
           <a:xfrm>
-            <a:off x="7594600" y="5814484"/>
+            <a:off x="7594600" y="5878282"/>
             <a:ext cx="1828802" cy="850898"/>
           </a:xfrm>
           <a:prstGeom prst="rect">
@@ -6204,7 +6204,7 @@
         </p:nvSpPr>
         <p:spPr>
           <a:xfrm>
-            <a:off x="7709483" y="683742"/>
+            <a:off x="8187948" y="1176887"/>
             <a:ext cx="3466518" cy="1371561"/>
           </a:xfrm>
           <a:prstGeom prst="cloud">
@@ -6258,6 +6258,543 @@
           </a:p>
         </p:txBody>
       </p:sp>
+      <p:graphicFrame>
+        <p:nvGraphicFramePr>
+          <p:cNvPr id="5" name="Table 4">
+            <a:extLst>
+              <a:ext uri="{FF2B5EF4-FFF2-40B4-BE49-F238E27FC236}">
+                <a16:creationId xmlns:a16="http://schemas.microsoft.com/office/drawing/2014/main" id="{2D061F1A-C981-68E8-414E-62123A1E6DAE}"/>
+              </a:ext>
+            </a:extLst>
+          </p:cNvPr>
+          <p:cNvGraphicFramePr>
+            <a:graphicFrameLocks noGrp="1"/>
+          </p:cNvGraphicFramePr>
+          <p:nvPr>
+            <p:extLst>
+              <p:ext uri="{D42A27DB-BD31-4B8C-83A1-F6EECF244321}">
+                <p14:modId xmlns:p14="http://schemas.microsoft.com/office/powerpoint/2010/main" val="1165089524"/>
+              </p:ext>
+            </p:extLst>
+          </p:nvPr>
+        </p:nvGraphicFramePr>
+        <p:xfrm>
+          <a:off x="265815" y="5160731"/>
+          <a:ext cx="4880340" cy="878171"/>
+        </p:xfrm>
+        <a:graphic>
+          <a:graphicData uri="http://schemas.openxmlformats.org/drawingml/2006/table">
+            <a:tbl>
+              <a:tblPr firstRow="1" bandRow="1">
+                <a:tableStyleId>{5C22544A-7EE6-4342-B048-85BDC9FD1C3A}</a:tableStyleId>
+              </a:tblPr>
+              <a:tblGrid>
+                <a:gridCol w="1626780">
+                  <a:extLst>
+                    <a:ext uri="{9D8B030D-6E8A-4147-A177-3AD203B41FA5}">
+                      <a16:colId xmlns:a16="http://schemas.microsoft.com/office/drawing/2014/main" val="335392651"/>
+                    </a:ext>
+                  </a:extLst>
+                </a:gridCol>
+                <a:gridCol w="1626780">
+                  <a:extLst>
+                    <a:ext uri="{9D8B030D-6E8A-4147-A177-3AD203B41FA5}">
+                      <a16:colId xmlns:a16="http://schemas.microsoft.com/office/drawing/2014/main" val="3951887457"/>
+                    </a:ext>
+                  </a:extLst>
+                </a:gridCol>
+                <a:gridCol w="1626780">
+                  <a:extLst>
+                    <a:ext uri="{9D8B030D-6E8A-4147-A177-3AD203B41FA5}">
+                      <a16:colId xmlns:a16="http://schemas.microsoft.com/office/drawing/2014/main" val="1268405609"/>
+                    </a:ext>
+                  </a:extLst>
+                </a:gridCol>
+              </a:tblGrid>
+              <a:tr h="259987">
+                <a:tc>
+                  <a:txBody>
+                    <a:bodyPr/>
+                    <a:lstStyle/>
+                    <a:p>
+                      <a:pPr algn="ctr"/>
+                      <a:r>
+                        <a:rPr lang="en-IE" sz="1400" dirty="0"/>
+                        <a:t>Field</a:t>
+                      </a:r>
+                    </a:p>
+                  </a:txBody>
+                  <a:tcPr anchor="ctr">
+                    <a:lnL w="12700" cap="flat" cmpd="sng" algn="ctr">
+                      <a:solidFill>
+                        <a:schemeClr val="tx1"/>
+                      </a:solidFill>
+                      <a:prstDash val="solid"/>
+                      <a:round/>
+                      <a:headEnd type="none" w="med" len="med"/>
+                      <a:tailEnd type="none" w="med" len="med"/>
+                    </a:lnL>
+                    <a:lnR w="12700" cap="flat" cmpd="sng" algn="ctr">
+                      <a:solidFill>
+                        <a:schemeClr val="tx1"/>
+                      </a:solidFill>
+                      <a:prstDash val="solid"/>
+                      <a:round/>
+                      <a:headEnd type="none" w="med" len="med"/>
+                      <a:tailEnd type="none" w="med" len="med"/>
+                    </a:lnR>
+                    <a:lnT w="12700" cap="flat" cmpd="sng" algn="ctr">
+                      <a:solidFill>
+                        <a:schemeClr val="tx1"/>
+                      </a:solidFill>
+                      <a:prstDash val="solid"/>
+                      <a:round/>
+                      <a:headEnd type="none" w="med" len="med"/>
+                      <a:tailEnd type="none" w="med" len="med"/>
+                    </a:lnT>
+                    <a:lnB w="12700" cap="flat" cmpd="sng" algn="ctr">
+                      <a:solidFill>
+                        <a:schemeClr val="tx1"/>
+                      </a:solidFill>
+                      <a:prstDash val="solid"/>
+                      <a:round/>
+                      <a:headEnd type="none" w="med" len="med"/>
+                      <a:tailEnd type="none" w="med" len="med"/>
+                    </a:lnB>
+                  </a:tcPr>
+                </a:tc>
+                <a:tc>
+                  <a:txBody>
+                    <a:bodyPr/>
+                    <a:lstStyle/>
+                    <a:p>
+                      <a:pPr algn="ctr"/>
+                      <a:r>
+                        <a:rPr lang="en-IE" sz="1400" dirty="0"/>
+                        <a:t>Data Type</a:t>
+                      </a:r>
+                    </a:p>
+                  </a:txBody>
+                  <a:tcPr anchor="ctr">
+                    <a:lnL w="12700" cap="flat" cmpd="sng" algn="ctr">
+                      <a:solidFill>
+                        <a:schemeClr val="tx1"/>
+                      </a:solidFill>
+                      <a:prstDash val="solid"/>
+                      <a:round/>
+                      <a:headEnd type="none" w="med" len="med"/>
+                      <a:tailEnd type="none" w="med" len="med"/>
+                    </a:lnL>
+                    <a:lnR w="12700" cap="flat" cmpd="sng" algn="ctr">
+                      <a:solidFill>
+                        <a:schemeClr val="tx1"/>
+                      </a:solidFill>
+                      <a:prstDash val="solid"/>
+                      <a:round/>
+                      <a:headEnd type="none" w="med" len="med"/>
+                      <a:tailEnd type="none" w="med" len="med"/>
+                    </a:lnR>
+                    <a:lnT w="12700" cap="flat" cmpd="sng" algn="ctr">
+                      <a:solidFill>
+                        <a:schemeClr val="tx1"/>
+                      </a:solidFill>
+                      <a:prstDash val="solid"/>
+                      <a:round/>
+                      <a:headEnd type="none" w="med" len="med"/>
+                      <a:tailEnd type="none" w="med" len="med"/>
+                    </a:lnT>
+                    <a:lnB w="12700" cap="flat" cmpd="sng" algn="ctr">
+                      <a:solidFill>
+                        <a:schemeClr val="tx1"/>
+                      </a:solidFill>
+                      <a:prstDash val="solid"/>
+                      <a:round/>
+                      <a:headEnd type="none" w="med" len="med"/>
+                      <a:tailEnd type="none" w="med" len="med"/>
+                    </a:lnB>
+                  </a:tcPr>
+                </a:tc>
+                <a:tc>
+                  <a:txBody>
+                    <a:bodyPr/>
+                    <a:lstStyle/>
+                    <a:p>
+                      <a:pPr algn="ctr"/>
+                      <a:r>
+                        <a:rPr lang="en-IE" sz="1400" dirty="0"/>
+                        <a:t>Purpose</a:t>
+                      </a:r>
+                    </a:p>
+                  </a:txBody>
+                  <a:tcPr anchor="ctr">
+                    <a:lnL w="12700" cap="flat" cmpd="sng" algn="ctr">
+                      <a:solidFill>
+                        <a:schemeClr val="tx1"/>
+                      </a:solidFill>
+                      <a:prstDash val="solid"/>
+                      <a:round/>
+                      <a:headEnd type="none" w="med" len="med"/>
+                      <a:tailEnd type="none" w="med" len="med"/>
+                    </a:lnL>
+                    <a:lnR w="12700" cap="flat" cmpd="sng" algn="ctr">
+                      <a:solidFill>
+                        <a:schemeClr val="tx1"/>
+                      </a:solidFill>
+                      <a:prstDash val="solid"/>
+                      <a:round/>
+                      <a:headEnd type="none" w="med" len="med"/>
+                      <a:tailEnd type="none" w="med" len="med"/>
+                    </a:lnR>
+                    <a:lnT w="12700" cap="flat" cmpd="sng" algn="ctr">
+                      <a:solidFill>
+                        <a:schemeClr val="tx1"/>
+                      </a:solidFill>
+                      <a:prstDash val="solid"/>
+                      <a:round/>
+                      <a:headEnd type="none" w="med" len="med"/>
+                      <a:tailEnd type="none" w="med" len="med"/>
+                    </a:lnT>
+                    <a:lnB w="12700" cap="flat" cmpd="sng" algn="ctr">
+                      <a:solidFill>
+                        <a:schemeClr val="tx1"/>
+                      </a:solidFill>
+                      <a:prstDash val="solid"/>
+                      <a:round/>
+                      <a:headEnd type="none" w="med" len="med"/>
+                      <a:tailEnd type="none" w="med" len="med"/>
+                    </a:lnB>
+                  </a:tcPr>
+                </a:tc>
+                <a:extLst>
+                  <a:ext uri="{0D108BD9-81ED-4DB2-BD59-A6C34878D82A}">
+                    <a16:rowId xmlns:a16="http://schemas.microsoft.com/office/drawing/2014/main" val="996559718"/>
+                  </a:ext>
+                </a:extLst>
+              </a:tr>
+              <a:tr h="299051">
+                <a:tc>
+                  <a:txBody>
+                    <a:bodyPr/>
+                    <a:lstStyle/>
+                    <a:p>
+                      <a:pPr algn="ctr"/>
+                      <a:r>
+                        <a:rPr lang="en-IE" sz="1200" dirty="0"/>
+                        <a:t>label</a:t>
+                      </a:r>
+                    </a:p>
+                  </a:txBody>
+                  <a:tcPr anchor="ctr">
+                    <a:lnL w="12700" cap="flat" cmpd="sng" algn="ctr">
+                      <a:solidFill>
+                        <a:schemeClr val="tx1"/>
+                      </a:solidFill>
+                      <a:prstDash val="solid"/>
+                      <a:round/>
+                      <a:headEnd type="none" w="med" len="med"/>
+                      <a:tailEnd type="none" w="med" len="med"/>
+                    </a:lnL>
+                    <a:lnR w="12700" cap="flat" cmpd="sng" algn="ctr">
+                      <a:solidFill>
+                        <a:schemeClr val="tx1"/>
+                      </a:solidFill>
+                      <a:prstDash val="solid"/>
+                      <a:round/>
+                      <a:headEnd type="none" w="med" len="med"/>
+                      <a:tailEnd type="none" w="med" len="med"/>
+                    </a:lnR>
+                    <a:lnT w="12700" cap="flat" cmpd="sng" algn="ctr">
+                      <a:solidFill>
+                        <a:schemeClr val="tx1"/>
+                      </a:solidFill>
+                      <a:prstDash val="solid"/>
+                      <a:round/>
+                      <a:headEnd type="none" w="med" len="med"/>
+                      <a:tailEnd type="none" w="med" len="med"/>
+                    </a:lnT>
+                    <a:lnB w="12700" cap="flat" cmpd="sng" algn="ctr">
+                      <a:solidFill>
+                        <a:schemeClr val="tx1"/>
+                      </a:solidFill>
+                      <a:prstDash val="solid"/>
+                      <a:round/>
+                      <a:headEnd type="none" w="med" len="med"/>
+                      <a:tailEnd type="none" w="med" len="med"/>
+                    </a:lnB>
+                  </a:tcPr>
+                </a:tc>
+                <a:tc>
+                  <a:txBody>
+                    <a:bodyPr/>
+                    <a:lstStyle/>
+                    <a:p>
+                      <a:pPr algn="ctr"/>
+                      <a:r>
+                        <a:rPr lang="en-IE" sz="1200" dirty="0"/>
+                        <a:t>string</a:t>
+                      </a:r>
+                    </a:p>
+                  </a:txBody>
+                  <a:tcPr anchor="ctr">
+                    <a:lnL w="12700" cap="flat" cmpd="sng" algn="ctr">
+                      <a:solidFill>
+                        <a:schemeClr val="tx1"/>
+                      </a:solidFill>
+                      <a:prstDash val="solid"/>
+                      <a:round/>
+                      <a:headEnd type="none" w="med" len="med"/>
+                      <a:tailEnd type="none" w="med" len="med"/>
+                    </a:lnL>
+                    <a:lnR w="12700" cap="flat" cmpd="sng" algn="ctr">
+                      <a:solidFill>
+                        <a:schemeClr val="tx1"/>
+                      </a:solidFill>
+                      <a:prstDash val="solid"/>
+                      <a:round/>
+                      <a:headEnd type="none" w="med" len="med"/>
+                      <a:tailEnd type="none" w="med" len="med"/>
+                    </a:lnR>
+                    <a:lnT w="12700" cap="flat" cmpd="sng" algn="ctr">
+                      <a:solidFill>
+                        <a:schemeClr val="tx1"/>
+                      </a:solidFill>
+                      <a:prstDash val="solid"/>
+                      <a:round/>
+                      <a:headEnd type="none" w="med" len="med"/>
+                      <a:tailEnd type="none" w="med" len="med"/>
+                    </a:lnT>
+                    <a:lnB w="12700" cap="flat" cmpd="sng" algn="ctr">
+                      <a:solidFill>
+                        <a:schemeClr val="tx1"/>
+                      </a:solidFill>
+                      <a:prstDash val="solid"/>
+                      <a:round/>
+                      <a:headEnd type="none" w="med" len="med"/>
+                      <a:tailEnd type="none" w="med" len="med"/>
+                    </a:lnB>
+                  </a:tcPr>
+                </a:tc>
+                <a:tc>
+                  <a:txBody>
+                    <a:bodyPr/>
+                    <a:lstStyle/>
+                    <a:p>
+                      <a:pPr algn="ctr"/>
+                      <a:r>
+                        <a:rPr lang="en-IE" sz="1200" dirty="0"/>
+                        <a:t>identifier</a:t>
+                      </a:r>
+                    </a:p>
+                  </a:txBody>
+                  <a:tcPr anchor="ctr">
+                    <a:lnL w="12700" cap="flat" cmpd="sng" algn="ctr">
+                      <a:solidFill>
+                        <a:schemeClr val="tx1"/>
+                      </a:solidFill>
+                      <a:prstDash val="solid"/>
+                      <a:round/>
+                      <a:headEnd type="none" w="med" len="med"/>
+                      <a:tailEnd type="none" w="med" len="med"/>
+                    </a:lnL>
+                    <a:lnR w="12700" cap="flat" cmpd="sng" algn="ctr">
+                      <a:solidFill>
+                        <a:schemeClr val="tx1"/>
+                      </a:solidFill>
+                      <a:prstDash val="solid"/>
+                      <a:round/>
+                      <a:headEnd type="none" w="med" len="med"/>
+                      <a:tailEnd type="none" w="med" len="med"/>
+                    </a:lnR>
+                    <a:lnT w="12700" cap="flat" cmpd="sng" algn="ctr">
+                      <a:solidFill>
+                        <a:schemeClr val="tx1"/>
+                      </a:solidFill>
+                      <a:prstDash val="solid"/>
+                      <a:round/>
+                      <a:headEnd type="none" w="med" len="med"/>
+                      <a:tailEnd type="none" w="med" len="med"/>
+                    </a:lnT>
+                    <a:lnB w="12700" cap="flat" cmpd="sng" algn="ctr">
+                      <a:solidFill>
+                        <a:schemeClr val="tx1"/>
+                      </a:solidFill>
+                      <a:prstDash val="solid"/>
+                      <a:round/>
+                      <a:headEnd type="none" w="med" len="med"/>
+                      <a:tailEnd type="none" w="med" len="med"/>
+                    </a:lnB>
+                  </a:tcPr>
+                </a:tc>
+                <a:extLst>
+                  <a:ext uri="{0D108BD9-81ED-4DB2-BD59-A6C34878D82A}">
+                    <a16:rowId xmlns:a16="http://schemas.microsoft.com/office/drawing/2014/main" val="3367568244"/>
+                  </a:ext>
+                </a:extLst>
+              </a:tr>
+              <a:tr h="252866">
+                <a:tc>
+                  <a:txBody>
+                    <a:bodyPr/>
+                    <a:lstStyle/>
+                    <a:p>
+                      <a:pPr algn="ctr"/>
+                      <a:r>
+                        <a:rPr lang="en-IE" sz="1200" dirty="0"/>
+                        <a:t>anno</a:t>
+                      </a:r>
+                    </a:p>
+                  </a:txBody>
+                  <a:tcPr anchor="ctr">
+                    <a:lnL w="12700" cap="flat" cmpd="sng" algn="ctr">
+                      <a:solidFill>
+                        <a:schemeClr val="tx1"/>
+                      </a:solidFill>
+                      <a:prstDash val="solid"/>
+                      <a:round/>
+                      <a:headEnd type="none" w="med" len="med"/>
+                      <a:tailEnd type="none" w="med" len="med"/>
+                    </a:lnL>
+                    <a:lnR w="12700" cap="flat" cmpd="sng" algn="ctr">
+                      <a:solidFill>
+                        <a:schemeClr val="tx1"/>
+                      </a:solidFill>
+                      <a:prstDash val="solid"/>
+                      <a:round/>
+                      <a:headEnd type="none" w="med" len="med"/>
+                      <a:tailEnd type="none" w="med" len="med"/>
+                    </a:lnR>
+                    <a:lnT w="12700" cap="flat" cmpd="sng" algn="ctr">
+                      <a:solidFill>
+                        <a:schemeClr val="tx1"/>
+                      </a:solidFill>
+                      <a:prstDash val="solid"/>
+                      <a:round/>
+                      <a:headEnd type="none" w="med" len="med"/>
+                      <a:tailEnd type="none" w="med" len="med"/>
+                    </a:lnT>
+                    <a:lnB w="12700" cap="flat" cmpd="sng" algn="ctr">
+                      <a:solidFill>
+                        <a:schemeClr val="tx1"/>
+                      </a:solidFill>
+                      <a:prstDash val="solid"/>
+                      <a:round/>
+                      <a:headEnd type="none" w="med" len="med"/>
+                      <a:tailEnd type="none" w="med" len="med"/>
+                    </a:lnB>
+                  </a:tcPr>
+                </a:tc>
+                <a:tc>
+                  <a:txBody>
+                    <a:bodyPr/>
+                    <a:lstStyle/>
+                    <a:p>
+                      <a:pPr algn="ctr"/>
+                      <a:r>
+                        <a:rPr lang="en-IE" sz="1200" dirty="0"/>
+                        <a:t>Map&lt;String, String&gt;</a:t>
+                      </a:r>
+                    </a:p>
+                  </a:txBody>
+                  <a:tcPr anchor="ctr">
+                    <a:lnL w="12700" cap="flat" cmpd="sng" algn="ctr">
+                      <a:solidFill>
+                        <a:schemeClr val="tx1"/>
+                      </a:solidFill>
+                      <a:prstDash val="solid"/>
+                      <a:round/>
+                      <a:headEnd type="none" w="med" len="med"/>
+                      <a:tailEnd type="none" w="med" len="med"/>
+                    </a:lnL>
+                    <a:lnR w="12700" cap="flat" cmpd="sng" algn="ctr">
+                      <a:solidFill>
+                        <a:schemeClr val="tx1"/>
+                      </a:solidFill>
+                      <a:prstDash val="solid"/>
+                      <a:round/>
+                      <a:headEnd type="none" w="med" len="med"/>
+                      <a:tailEnd type="none" w="med" len="med"/>
+                    </a:lnR>
+                    <a:lnT w="12700" cap="flat" cmpd="sng" algn="ctr">
+                      <a:solidFill>
+                        <a:schemeClr val="tx1"/>
+                      </a:solidFill>
+                      <a:prstDash val="solid"/>
+                      <a:round/>
+                      <a:headEnd type="none" w="med" len="med"/>
+                      <a:tailEnd type="none" w="med" len="med"/>
+                    </a:lnT>
+                    <a:lnB w="12700" cap="flat" cmpd="sng" algn="ctr">
+                      <a:solidFill>
+                        <a:schemeClr val="tx1"/>
+                      </a:solidFill>
+                      <a:prstDash val="solid"/>
+                      <a:round/>
+                      <a:headEnd type="none" w="med" len="med"/>
+                      <a:tailEnd type="none" w="med" len="med"/>
+                    </a:lnB>
+                  </a:tcPr>
+                </a:tc>
+                <a:tc>
+                  <a:txBody>
+                    <a:bodyPr/>
+                    <a:lstStyle/>
+                    <a:p>
+                      <a:pPr algn="ctr"/>
+                      <a:r>
+                        <a:rPr lang="en-IE" sz="1200" dirty="0"/>
+                        <a:t>Annotation</a:t>
+                      </a:r>
+                    </a:p>
+                  </a:txBody>
+                  <a:tcPr anchor="ctr">
+                    <a:lnL w="12700" cap="flat" cmpd="sng" algn="ctr">
+                      <a:solidFill>
+                        <a:schemeClr val="tx1"/>
+                      </a:solidFill>
+                      <a:prstDash val="solid"/>
+                      <a:round/>
+                      <a:headEnd type="none" w="med" len="med"/>
+                      <a:tailEnd type="none" w="med" len="med"/>
+                    </a:lnL>
+                    <a:lnR w="12700" cap="flat" cmpd="sng" algn="ctr">
+                      <a:solidFill>
+                        <a:schemeClr val="tx1"/>
+                      </a:solidFill>
+                      <a:prstDash val="solid"/>
+                      <a:round/>
+                      <a:headEnd type="none" w="med" len="med"/>
+                      <a:tailEnd type="none" w="med" len="med"/>
+                    </a:lnR>
+                    <a:lnT w="12700" cap="flat" cmpd="sng" algn="ctr">
+                      <a:solidFill>
+                        <a:schemeClr val="tx1"/>
+                      </a:solidFill>
+                      <a:prstDash val="solid"/>
+                      <a:round/>
+                      <a:headEnd type="none" w="med" len="med"/>
+                      <a:tailEnd type="none" w="med" len="med"/>
+                    </a:lnT>
+                    <a:lnB w="12700" cap="flat" cmpd="sng" algn="ctr">
+                      <a:solidFill>
+                        <a:schemeClr val="tx1"/>
+                      </a:solidFill>
+                      <a:prstDash val="solid"/>
+                      <a:round/>
+                      <a:headEnd type="none" w="med" len="med"/>
+                      <a:tailEnd type="none" w="med" len="med"/>
+                    </a:lnB>
+                  </a:tcPr>
+                </a:tc>
+                <a:extLst>
+                  <a:ext uri="{0D108BD9-81ED-4DB2-BD59-A6C34878D82A}">
+                    <a16:rowId xmlns:a16="http://schemas.microsoft.com/office/drawing/2014/main" val="830240925"/>
+                  </a:ext>
+                </a:extLst>
+              </a:tr>
+            </a:tbl>
+          </a:graphicData>
+        </a:graphic>
+      </p:graphicFrame>
     </p:spTree>
     <p:extLst>
       <p:ext uri="{BB962C8B-B14F-4D97-AF65-F5344CB8AC3E}">

</xml_diff>

<commit_message>
NeuroTraceR Logo + Stylings + Sandbox page
</commit_message>
<xml_diff>
--- a/design.pptx
+++ b/design.pptx
@@ -5,15 +5,16 @@
     <p:sldMasterId id="2147483648" r:id="rId1"/>
   </p:sldMasterIdLst>
   <p:notesMasterIdLst>
-    <p:notesMasterId r:id="rId8"/>
+    <p:notesMasterId r:id="rId9"/>
   </p:notesMasterIdLst>
   <p:sldIdLst>
-    <p:sldId id="261" r:id="rId2"/>
-    <p:sldId id="256" r:id="rId3"/>
-    <p:sldId id="257" r:id="rId4"/>
-    <p:sldId id="260" r:id="rId5"/>
-    <p:sldId id="258" r:id="rId6"/>
-    <p:sldId id="259" r:id="rId7"/>
+    <p:sldId id="262" r:id="rId2"/>
+    <p:sldId id="261" r:id="rId3"/>
+    <p:sldId id="256" r:id="rId4"/>
+    <p:sldId id="257" r:id="rId5"/>
+    <p:sldId id="260" r:id="rId6"/>
+    <p:sldId id="258" r:id="rId7"/>
+    <p:sldId id="259" r:id="rId8"/>
   </p:sldIdLst>
   <p:sldSz cx="12192000" cy="6858000"/>
   <p:notesSz cx="6858000" cy="9144000"/>
@@ -202,7 +203,7 @@
           <a:p>
             <a:fld id="{6FA4EDF4-EE0E-49B4-B826-F9C1BBE68B05}" type="datetimeFigureOut">
               <a:rPr lang="en-IE" smtClean="0"/>
-              <a:t>13/10/2026</a:t>
+              <a:t>14/10/2026</a:t>
             </a:fld>
             <a:endParaRPr lang="en-IE"/>
           </a:p>
@@ -538,7 +539,7 @@
           <a:p>
             <a:fld id="{E82F2BA2-9329-46AC-9623-676651B08B3C}" type="slidenum">
               <a:rPr lang="en-IE" smtClean="0"/>
-              <a:t>2</a:t>
+              <a:t>3</a:t>
             </a:fld>
             <a:endParaRPr lang="en-IE"/>
           </a:p>
@@ -706,7 +707,7 @@
           <a:p>
             <a:fld id="{830E50AA-C841-416D-81BB-884671257748}" type="datetimeFigureOut">
               <a:rPr lang="en-IE" smtClean="0"/>
-              <a:t>13/10/2026</a:t>
+              <a:t>14/10/2026</a:t>
             </a:fld>
             <a:endParaRPr lang="en-IE"/>
           </a:p>
@@ -906,7 +907,7 @@
           <a:p>
             <a:fld id="{830E50AA-C841-416D-81BB-884671257748}" type="datetimeFigureOut">
               <a:rPr lang="en-IE" smtClean="0"/>
-              <a:t>13/10/2026</a:t>
+              <a:t>14/10/2026</a:t>
             </a:fld>
             <a:endParaRPr lang="en-IE"/>
           </a:p>
@@ -1116,7 +1117,7 @@
           <a:p>
             <a:fld id="{830E50AA-C841-416D-81BB-884671257748}" type="datetimeFigureOut">
               <a:rPr lang="en-IE" smtClean="0"/>
-              <a:t>13/10/2026</a:t>
+              <a:t>14/10/2026</a:t>
             </a:fld>
             <a:endParaRPr lang="en-IE"/>
           </a:p>
@@ -1316,7 +1317,7 @@
           <a:p>
             <a:fld id="{830E50AA-C841-416D-81BB-884671257748}" type="datetimeFigureOut">
               <a:rPr lang="en-IE" smtClean="0"/>
-              <a:t>13/10/2026</a:t>
+              <a:t>14/10/2026</a:t>
             </a:fld>
             <a:endParaRPr lang="en-IE"/>
           </a:p>
@@ -1592,7 +1593,7 @@
           <a:p>
             <a:fld id="{830E50AA-C841-416D-81BB-884671257748}" type="datetimeFigureOut">
               <a:rPr lang="en-IE" smtClean="0"/>
-              <a:t>13/10/2026</a:t>
+              <a:t>14/10/2026</a:t>
             </a:fld>
             <a:endParaRPr lang="en-IE"/>
           </a:p>
@@ -1860,7 +1861,7 @@
           <a:p>
             <a:fld id="{830E50AA-C841-416D-81BB-884671257748}" type="datetimeFigureOut">
               <a:rPr lang="en-IE" smtClean="0"/>
-              <a:t>13/10/2026</a:t>
+              <a:t>14/10/2026</a:t>
             </a:fld>
             <a:endParaRPr lang="en-IE"/>
           </a:p>
@@ -2275,7 +2276,7 @@
           <a:p>
             <a:fld id="{830E50AA-C841-416D-81BB-884671257748}" type="datetimeFigureOut">
               <a:rPr lang="en-IE" smtClean="0"/>
-              <a:t>13/10/2026</a:t>
+              <a:t>14/10/2026</a:t>
             </a:fld>
             <a:endParaRPr lang="en-IE"/>
           </a:p>
@@ -2417,7 +2418,7 @@
           <a:p>
             <a:fld id="{830E50AA-C841-416D-81BB-884671257748}" type="datetimeFigureOut">
               <a:rPr lang="en-IE" smtClean="0"/>
-              <a:t>13/10/2026</a:t>
+              <a:t>14/10/2026</a:t>
             </a:fld>
             <a:endParaRPr lang="en-IE"/>
           </a:p>
@@ -2530,7 +2531,7 @@
           <a:p>
             <a:fld id="{830E50AA-C841-416D-81BB-884671257748}" type="datetimeFigureOut">
               <a:rPr lang="en-IE" smtClean="0"/>
-              <a:t>13/10/2026</a:t>
+              <a:t>14/10/2026</a:t>
             </a:fld>
             <a:endParaRPr lang="en-IE"/>
           </a:p>
@@ -2843,7 +2844,7 @@
           <a:p>
             <a:fld id="{830E50AA-C841-416D-81BB-884671257748}" type="datetimeFigureOut">
               <a:rPr lang="en-IE" smtClean="0"/>
-              <a:t>13/10/2026</a:t>
+              <a:t>14/10/2026</a:t>
             </a:fld>
             <a:endParaRPr lang="en-IE"/>
           </a:p>
@@ -3132,7 +3133,7 @@
           <a:p>
             <a:fld id="{830E50AA-C841-416D-81BB-884671257748}" type="datetimeFigureOut">
               <a:rPr lang="en-IE" smtClean="0"/>
-              <a:t>13/10/2026</a:t>
+              <a:t>14/10/2026</a:t>
             </a:fld>
             <a:endParaRPr lang="en-IE"/>
           </a:p>
@@ -3375,7 +3376,7 @@
           <a:p>
             <a:fld id="{830E50AA-C841-416D-81BB-884671257748}" type="datetimeFigureOut">
               <a:rPr lang="en-IE" smtClean="0"/>
-              <a:t>13/10/2026</a:t>
+              <a:t>14/10/2026</a:t>
             </a:fld>
             <a:endParaRPr lang="en-IE"/>
           </a:p>
@@ -3776,6 +3777,162 @@
 </file>
 
 <file path=ppt/slides/slide1.xml><?xml version="1.0" encoding="utf-8"?>
+<p:sld xmlns:a="http://schemas.openxmlformats.org/drawingml/2006/main" xmlns:r="http://schemas.openxmlformats.org/officeDocument/2006/relationships" xmlns:p="http://schemas.openxmlformats.org/presentationml/2006/main">
+  <p:cSld>
+    <p:spTree>
+      <p:nvGrpSpPr>
+        <p:cNvPr id="1" name=""/>
+        <p:cNvGrpSpPr/>
+        <p:nvPr/>
+      </p:nvGrpSpPr>
+      <p:grpSpPr>
+        <a:xfrm>
+          <a:off x="0" y="0"/>
+          <a:ext cx="0" cy="0"/>
+          <a:chOff x="0" y="0"/>
+          <a:chExt cx="0" cy="0"/>
+        </a:xfrm>
+      </p:grpSpPr>
+      <p:pic>
+        <p:nvPicPr>
+          <p:cNvPr id="7" name="Picture 6">
+            <a:extLst>
+              <a:ext uri="{FF2B5EF4-FFF2-40B4-BE49-F238E27FC236}">
+                <a16:creationId xmlns:a16="http://schemas.microsoft.com/office/drawing/2014/main" id="{E9E35D96-E370-115B-9498-6E359E92AF3F}"/>
+              </a:ext>
+            </a:extLst>
+          </p:cNvPr>
+          <p:cNvPicPr>
+            <a:picLocks noChangeAspect="1"/>
+          </p:cNvPicPr>
+          <p:nvPr/>
+        </p:nvPicPr>
+        <p:blipFill>
+          <a:blip r:embed="rId2"/>
+          <a:stretch>
+            <a:fillRect/>
+          </a:stretch>
+        </p:blipFill>
+        <p:spPr>
+          <a:xfrm>
+            <a:off x="318006" y="169555"/>
+            <a:ext cx="3985605" cy="777307"/>
+          </a:xfrm>
+          <a:prstGeom prst="rect">
+            <a:avLst/>
+          </a:prstGeom>
+        </p:spPr>
+      </p:pic>
+      <p:pic>
+        <p:nvPicPr>
+          <p:cNvPr id="9" name="Picture 8">
+            <a:extLst>
+              <a:ext uri="{FF2B5EF4-FFF2-40B4-BE49-F238E27FC236}">
+                <a16:creationId xmlns:a16="http://schemas.microsoft.com/office/drawing/2014/main" id="{EF490C4B-2099-C430-4B94-AC4D82E8EF90}"/>
+              </a:ext>
+            </a:extLst>
+          </p:cNvPr>
+          <p:cNvPicPr>
+            <a:picLocks noChangeAspect="1"/>
+          </p:cNvPicPr>
+          <p:nvPr/>
+        </p:nvPicPr>
+        <p:blipFill>
+          <a:blip r:embed="rId3">
+            <a:extLst>
+              <a:ext uri="{28A0092B-C50C-407E-A947-70E740481C1C}">
+                <a14:useLocalDpi xmlns:a14="http://schemas.microsoft.com/office/drawing/2010/main" val="0"/>
+              </a:ext>
+            </a:extLst>
+          </a:blip>
+          <a:stretch>
+            <a:fillRect/>
+          </a:stretch>
+        </p:blipFill>
+        <p:spPr>
+          <a:xfrm>
+            <a:off x="1050851" y="1467293"/>
+            <a:ext cx="7495953" cy="4997302"/>
+          </a:xfrm>
+          <a:prstGeom prst="rect">
+            <a:avLst/>
+          </a:prstGeom>
+        </p:spPr>
+      </p:pic>
+      <p:pic>
+        <p:nvPicPr>
+          <p:cNvPr id="11" name="Picture 10">
+            <a:extLst>
+              <a:ext uri="{FF2B5EF4-FFF2-40B4-BE49-F238E27FC236}">
+                <a16:creationId xmlns:a16="http://schemas.microsoft.com/office/drawing/2014/main" id="{B5DB8B3E-CBA4-7A90-E9D2-8E9B1924C074}"/>
+              </a:ext>
+            </a:extLst>
+          </p:cNvPr>
+          <p:cNvPicPr>
+            <a:picLocks noChangeAspect="1"/>
+          </p:cNvPicPr>
+          <p:nvPr/>
+        </p:nvPicPr>
+        <p:blipFill>
+          <a:blip r:embed="rId4"/>
+          <a:stretch>
+            <a:fillRect/>
+          </a:stretch>
+        </p:blipFill>
+        <p:spPr>
+          <a:xfrm>
+            <a:off x="1624948" y="946862"/>
+            <a:ext cx="1371719" cy="624894"/>
+          </a:xfrm>
+          <a:prstGeom prst="rect">
+            <a:avLst/>
+          </a:prstGeom>
+        </p:spPr>
+      </p:pic>
+      <p:pic>
+        <p:nvPicPr>
+          <p:cNvPr id="13" name="Picture 12">
+            <a:extLst>
+              <a:ext uri="{FF2B5EF4-FFF2-40B4-BE49-F238E27FC236}">
+                <a16:creationId xmlns:a16="http://schemas.microsoft.com/office/drawing/2014/main" id="{E5ABD560-E35F-A92A-5D9C-B7D572B80F52}"/>
+              </a:ext>
+            </a:extLst>
+          </p:cNvPr>
+          <p:cNvPicPr>
+            <a:picLocks noChangeAspect="1"/>
+          </p:cNvPicPr>
+          <p:nvPr/>
+        </p:nvPicPr>
+        <p:blipFill>
+          <a:blip r:embed="rId5"/>
+          <a:stretch>
+            <a:fillRect/>
+          </a:stretch>
+        </p:blipFill>
+        <p:spPr>
+          <a:xfrm>
+            <a:off x="8170353" y="132565"/>
+            <a:ext cx="3703641" cy="2149026"/>
+          </a:xfrm>
+          <a:prstGeom prst="rect">
+            <a:avLst/>
+          </a:prstGeom>
+        </p:spPr>
+      </p:pic>
+    </p:spTree>
+    <p:extLst>
+      <p:ext uri="{BB962C8B-B14F-4D97-AF65-F5344CB8AC3E}">
+        <p14:creationId xmlns:p14="http://schemas.microsoft.com/office/powerpoint/2010/main" val="484792212"/>
+      </p:ext>
+    </p:extLst>
+  </p:cSld>
+  <p:clrMapOvr>
+    <a:masterClrMapping/>
+  </p:clrMapOvr>
+</p:sld>
+</file>
+
+<file path=ppt/slides/slide2.xml><?xml version="1.0" encoding="utf-8"?>
 <p:sld xmlns:a="http://schemas.openxmlformats.org/drawingml/2006/main" xmlns:r="http://schemas.openxmlformats.org/officeDocument/2006/relationships" xmlns:p="http://schemas.openxmlformats.org/presentationml/2006/main">
   <p:cSld>
     <p:spTree>
@@ -4370,7 +4527,7 @@
 </p:sld>
 </file>
 
-<file path=ppt/slides/slide2.xml><?xml version="1.0" encoding="utf-8"?>
+<file path=ppt/slides/slide3.xml><?xml version="1.0" encoding="utf-8"?>
 <p:sld xmlns:a="http://schemas.openxmlformats.org/drawingml/2006/main" xmlns:r="http://schemas.openxmlformats.org/officeDocument/2006/relationships" xmlns:p="http://schemas.openxmlformats.org/presentationml/2006/main">
   <p:cSld>
     <p:spTree>
@@ -4616,7 +4773,7 @@
 </p:sld>
 </file>
 
-<file path=ppt/slides/slide3.xml><?xml version="1.0" encoding="utf-8"?>
+<file path=ppt/slides/slide4.xml><?xml version="1.0" encoding="utf-8"?>
 <p:sld xmlns:a="http://schemas.openxmlformats.org/drawingml/2006/main" xmlns:r="http://schemas.openxmlformats.org/officeDocument/2006/relationships" xmlns:p="http://schemas.openxmlformats.org/presentationml/2006/main">
   <p:cSld>
     <p:spTree>
@@ -5013,7 +5170,7 @@
 </p:sld>
 </file>
 
-<file path=ppt/slides/slide4.xml><?xml version="1.0" encoding="utf-8"?>
+<file path=ppt/slides/slide5.xml><?xml version="1.0" encoding="utf-8"?>
 <p:sld xmlns:a="http://schemas.openxmlformats.org/drawingml/2006/main" xmlns:r="http://schemas.openxmlformats.org/officeDocument/2006/relationships" xmlns:p="http://schemas.openxmlformats.org/presentationml/2006/main">
   <p:cSld>
     <p:spTree>
@@ -5449,7 +5606,7 @@
 </p:sld>
 </file>
 
-<file path=ppt/slides/slide5.xml><?xml version="1.0" encoding="utf-8"?>
+<file path=ppt/slides/slide6.xml><?xml version="1.0" encoding="utf-8"?>
 <p:sld xmlns:a="http://schemas.openxmlformats.org/drawingml/2006/main" xmlns:r="http://schemas.openxmlformats.org/officeDocument/2006/relationships" xmlns:p="http://schemas.openxmlformats.org/presentationml/2006/main">
   <p:cSld>
     <p:spTree>
@@ -6808,7 +6965,7 @@
 </p:sld>
 </file>
 
-<file path=ppt/slides/slide6.xml><?xml version="1.0" encoding="utf-8"?>
+<file path=ppt/slides/slide7.xml><?xml version="1.0" encoding="utf-8"?>
 <p:sld xmlns:a="http://schemas.openxmlformats.org/drawingml/2006/main" xmlns:r="http://schemas.openxmlformats.org/officeDocument/2006/relationships" xmlns:p="http://schemas.openxmlformats.org/presentationml/2006/main">
   <p:cSld>
     <p:spTree>

</xml_diff>